<commit_message>
Replace pricing with xx placeholders across deck and all pages
</commit_message>
<xml_diff>
--- a/public/telecom-ai-strategy-deck.pptx
+++ b/public/telecom-ai-strategy-deck.pptx
@@ -6642,7 +6642,7 @@
                 <a:ea typeface="Yango Text" pitchFamily="34" charset="-122"/>
                 <a:cs typeface="Yango Text" pitchFamily="34" charset="-120"/>
               </a:rPr>
-              <a:t>$8–$25/user/month. Doc analysis, code gen, data queries. Full tenant isolation. 85% gross margin.</a:t>
+              <a:t>$xx/user/month. Doc analysis, code gen, data queries. Full tenant isolation. High gross margin.</a:t>
             </a:r>
             <a:endParaRPr lang="en-US" sz="1050" dirty="0"/>
           </a:p>
@@ -7385,7 +7385,7 @@
                 <a:ea typeface="Yango Text" pitchFamily="34" charset="-122"/>
                 <a:cs typeface="Yango Text" pitchFamily="34" charset="-120"/>
               </a:rPr>
-              <a:t>that handle voice and chat in 30+ languages. They pay monthly — you keep 60%+ margin.</a:t>
+              <a:t>that handle voice and chat in 30+ languages. They pay monthly — you keep strong margin.</a:t>
             </a:r>
             <a:endParaRPr lang="en-US" sz="1400" dirty="0"/>
           </a:p>
@@ -8637,7 +8637,7 @@
                 <a:ea typeface="Yango Text" pitchFamily="34" charset="-122"/>
                 <a:cs typeface="Yango Text" pitchFamily="34" charset="-120"/>
               </a:rPr>
-              <a:t>CRM, document stores. Each enterprise pays per user per month. 85% gross margin.</a:t>
+              <a:t>CRM, document stores. Each enterprise pays per user per month. High gross margin.</a:t>
             </a:r>
             <a:endParaRPr lang="en-US" sz="1400" dirty="0"/>
           </a:p>
@@ -8892,7 +8892,7 @@
                 <a:ea typeface="Yango Text Bold" pitchFamily="34" charset="-122"/>
                 <a:cs typeface="Yango Text Bold" pitchFamily="34" charset="-120"/>
               </a:rPr>
-              <a:t>$8–$25 per user per month</a:t>
+              <a:t>Per-user monthly pricing</a:t>
             </a:r>
             <a:endParaRPr lang="en-US" sz="1200" dirty="0"/>
           </a:p>
@@ -8931,7 +8931,7 @@
                 <a:ea typeface="Yango Text" pitchFamily="34" charset="-122"/>
                 <a:cs typeface="Yango Text" pitchFamily="34" charset="-120"/>
               </a:rPr>
-              <a:t>Basic (docs), Pro (integrations), Enterprise (custom models)</a:t>
+              <a:t>Tiered: Basic (docs), Pro (integrations), Enterprise (custom models)</a:t>
             </a:r>
             <a:endParaRPr lang="en-US" sz="1000" dirty="0"/>
           </a:p>
@@ -8990,7 +8990,7 @@
                 <a:ea typeface="Yango Text Bold" pitchFamily="34" charset="-122"/>
                 <a:cs typeface="Yango Text Bold" pitchFamily="34" charset="-120"/>
               </a:rPr>
-              <a:t>85% gross margin at scale</a:t>
+              <a:t>High gross margin at scale</a:t>
             </a:r>
             <a:endParaRPr lang="en-US" sz="1200" dirty="0"/>
           </a:p>
@@ -9899,7 +9899,7 @@
                 <a:ea typeface="Yango Text Bold" pitchFamily="34" charset="-122"/>
                 <a:cs typeface="Yango Text Bold" pitchFamily="34" charset="-120"/>
               </a:rPr>
-              <a:t>$2.40/GPU-hr, 60%+ margin</a:t>
+              <a:t>Per GPU-hour pricing, strong margin</a:t>
             </a:r>
             <a:endParaRPr lang="en-US" sz="1200" dirty="0"/>
           </a:p>
@@ -10231,7 +10231,7 @@
                 <a:ea typeface="Yango Headline Black" pitchFamily="34" charset="-122"/>
                 <a:cs typeface="Yango Headline Black" pitchFamily="34" charset="-120"/>
               </a:rPr>
-              <a:t>$847K</a:t>
+              <a:t>$xxK</a:t>
             </a:r>
             <a:endParaRPr lang="en-US" sz="2000" dirty="0"/>
           </a:p>
@@ -11270,7 +11270,7 @@
                 <a:ea typeface="Yango Headline Black" pitchFamily="34" charset="-122"/>
                 <a:cs typeface="Yango Headline Black" pitchFamily="34" charset="-120"/>
               </a:rPr>
-              <a:t>$8</a:t>
+              <a:t>$xx</a:t>
             </a:r>
             <a:endParaRPr lang="en-US" sz="3600" dirty="0"/>
           </a:p>
@@ -11465,7 +11465,7 @@
                 <a:ea typeface="Yango Text" pitchFamily="34" charset="-122"/>
                 <a:cs typeface="Yango Text" pitchFamily="34" charset="-120"/>
               </a:rPr>
-              <a:t>•  5,000 AI tokens / user / day</a:t>
+              <a:t>•  AI tokens / user / day — TBD</a:t>
             </a:r>
             <a:endParaRPr lang="en-US" sz="1000" dirty="0"/>
           </a:p>
@@ -11504,7 +11504,7 @@
                 <a:ea typeface="Yango Text" pitchFamily="34" charset="-122"/>
                 <a:cs typeface="Yango Text" pitchFamily="34" charset="-120"/>
               </a:rPr>
-              <a:t>~75% GROSS MARGIN</a:t>
+              <a:t>~xx% GROSS MARGIN</a:t>
             </a:r>
             <a:endParaRPr lang="en-US" sz="900" dirty="0"/>
           </a:p>
@@ -11645,7 +11645,7 @@
                 <a:ea typeface="Yango Headline Black" pitchFamily="34" charset="-122"/>
                 <a:cs typeface="Yango Headline Black" pitchFamily="34" charset="-120"/>
               </a:rPr>
-              <a:t>$18</a:t>
+              <a:t>$xx</a:t>
             </a:r>
             <a:endParaRPr lang="en-US" sz="3600" dirty="0"/>
           </a:p>
@@ -11879,7 +11879,7 @@
                 <a:ea typeface="Yango Text" pitchFamily="34" charset="-122"/>
                 <a:cs typeface="Yango Text" pitchFamily="34" charset="-120"/>
               </a:rPr>
-              <a:t>•  25,000 tokens / user / day</a:t>
+              <a:t>•  AI tokens / user / day — TBD</a:t>
             </a:r>
             <a:endParaRPr lang="en-US" sz="1000" dirty="0"/>
           </a:p>
@@ -11918,7 +11918,7 @@
                 <a:ea typeface="Yango Text" pitchFamily="34" charset="-122"/>
                 <a:cs typeface="Yango Text" pitchFamily="34" charset="-120"/>
               </a:rPr>
-              <a:t>~82% GROSS MARGIN</a:t>
+              <a:t>~xx% GROSS MARGIN</a:t>
             </a:r>
             <a:endParaRPr lang="en-US" sz="900" dirty="0"/>
           </a:p>
@@ -12039,7 +12039,7 @@
                 <a:ea typeface="Yango Headline Black" pitchFamily="34" charset="-122"/>
                 <a:cs typeface="Yango Headline Black" pitchFamily="34" charset="-120"/>
               </a:rPr>
-              <a:t>$2.40</a:t>
+              <a:t>$xx</a:t>
             </a:r>
             <a:endParaRPr lang="en-US" sz="3600" dirty="0"/>
           </a:p>
@@ -12312,7 +12312,7 @@
                 <a:ea typeface="Yango Text" pitchFamily="34" charset="-122"/>
                 <a:cs typeface="Yango Text" pitchFamily="34" charset="-120"/>
               </a:rPr>
-              <a:t>~60% GROSS MARGIN</a:t>
+              <a:t>~xx% GROSS MARGIN</a:t>
             </a:r>
             <a:endParaRPr lang="en-US" sz="900" dirty="0"/>
           </a:p>
@@ -12504,7 +12504,7 @@
                 <a:ea typeface="Yango Text" pitchFamily="34" charset="-122"/>
                 <a:cs typeface="Yango Text" pitchFamily="34" charset="-120"/>
               </a:rPr>
-              <a:t>Enterprise AI Assistant — 5,000 users @ $18/mo avg</a:t>
+              <a:t>Enterprise AI Assistant — xx users @ $xx/mo avg</a:t>
             </a:r>
             <a:endParaRPr lang="en-US" sz="1200" dirty="0"/>
           </a:p>
@@ -12543,7 +12543,7 @@
                 <a:ea typeface="Yango Text Bold" pitchFamily="34" charset="-122"/>
                 <a:cs typeface="Yango Text Bold" pitchFamily="34" charset="-120"/>
               </a:rPr>
-              <a:t>$90K / month</a:t>
+              <a:t>$xxK / month</a:t>
             </a:r>
             <a:endParaRPr lang="en-US" sz="1200" dirty="0"/>
           </a:p>
@@ -12602,7 +12602,7 @@
                 <a:ea typeface="Yango Text" pitchFamily="34" charset="-122"/>
                 <a:cs typeface="Yango Text" pitchFamily="34" charset="-120"/>
               </a:rPr>
-              <a:t>AI Contact Center — 3 enterprise clients @ $25K/mo</a:t>
+              <a:t>AI Contact Center — xx enterprise clients @ $xxK/mo</a:t>
             </a:r>
             <a:endParaRPr lang="en-US" sz="1200" dirty="0"/>
           </a:p>
@@ -12641,7 +12641,7 @@
                 <a:ea typeface="Yango Text Bold" pitchFamily="34" charset="-122"/>
                 <a:cs typeface="Yango Text Bold" pitchFamily="34" charset="-120"/>
               </a:rPr>
-              <a:t>$75K / month</a:t>
+              <a:t>$xxK / month</a:t>
             </a:r>
             <a:endParaRPr lang="en-US" sz="1200" dirty="0"/>
           </a:p>
@@ -12700,7 +12700,7 @@
                 <a:ea typeface="Yango Text" pitchFamily="34" charset="-122"/>
                 <a:cs typeface="Yango Text" pitchFamily="34" charset="-120"/>
               </a:rPr>
-              <a:t>GPU-as-a-Service — 200 GPU-hrs/day @ $2.40</a:t>
+              <a:t>GPU-as-a-Service — xx GPU-hrs/day @ $xx</a:t>
             </a:r>
             <a:endParaRPr lang="en-US" sz="1200" dirty="0"/>
           </a:p>
@@ -12739,7 +12739,7 @@
                 <a:ea typeface="Yango Text Bold" pitchFamily="34" charset="-122"/>
                 <a:cs typeface="Yango Text Bold" pitchFamily="34" charset="-120"/>
               </a:rPr>
-              <a:t>$14.4K / month</a:t>
+              <a:t>$xxK / month</a:t>
             </a:r>
             <a:endParaRPr lang="en-US" sz="1200" dirty="0"/>
           </a:p>
@@ -12798,7 +12798,7 @@
                 <a:ea typeface="Yango Text" pitchFamily="34" charset="-122"/>
                 <a:cs typeface="Yango Text" pitchFamily="34" charset="-120"/>
               </a:rPr>
-              <a:t>SMB AI Bundle — 10,000 SMBs @ $5/mo add-on</a:t>
+              <a:t>SMB AI Bundle — xx SMBs @ $xx/mo add-on</a:t>
             </a:r>
             <a:endParaRPr lang="en-US" sz="1200" dirty="0"/>
           </a:p>
@@ -12837,7 +12837,7 @@
                 <a:ea typeface="Yango Text Bold" pitchFamily="34" charset="-122"/>
                 <a:cs typeface="Yango Text Bold" pitchFamily="34" charset="-120"/>
               </a:rPr>
-              <a:t>$50K / month</a:t>
+              <a:t>$xxK / month</a:t>
             </a:r>
             <a:endParaRPr lang="en-US" sz="1200" dirty="0"/>
           </a:p>
@@ -12935,7 +12935,7 @@
                 <a:ea typeface="Yango Text Bold" pitchFamily="34" charset="-122"/>
                 <a:cs typeface="Yango Text Bold" pitchFamily="34" charset="-120"/>
               </a:rPr>
-              <a:t>$40K / month</a:t>
+              <a:t>$xxK / month</a:t>
             </a:r>
             <a:endParaRPr lang="en-US" sz="1200" dirty="0"/>
           </a:p>
@@ -13033,7 +13033,7 @@
                 <a:ea typeface="Yango Headline Black" pitchFamily="34" charset="-122"/>
                 <a:cs typeface="Yango Headline Black" pitchFamily="34" charset="-120"/>
               </a:rPr>
-              <a:t>$269K</a:t>
+              <a:t>$xxK</a:t>
             </a:r>
             <a:endParaRPr lang="en-US" sz="2800" dirty="0"/>
           </a:p>
@@ -13072,7 +13072,7 @@
                 <a:ea typeface="Yango Text" pitchFamily="34" charset="-122"/>
                 <a:cs typeface="Yango Text" pitchFamily="34" charset="-120"/>
               </a:rPr>
-              <a:t>$3.2M ANNUALIZED  ·  YEAR 1 TARGET  ·  SINGLE MARKET</a:t>
+              <a:t>$xxM ANNUALIZED  ·  YEAR 1 TARGET  ·  SINGLE MARKET</a:t>
             </a:r>
             <a:endParaRPr lang="en-US" sz="700" dirty="0"/>
           </a:p>
@@ -21500,7 +21500,7 @@
                 <a:ea typeface="Yango Headline Black" pitchFamily="34" charset="-122"/>
                 <a:cs typeface="Yango Headline Black" pitchFamily="34" charset="-120"/>
               </a:rPr>
-              <a:t>20–30%</a:t>
+              <a:t>xx–xx%</a:t>
             </a:r>
             <a:endParaRPr lang="en-US" sz="2800" dirty="0"/>
           </a:p>
@@ -21794,7 +21794,7 @@
                 <a:ea typeface="Yango Text" pitchFamily="34" charset="-122"/>
                 <a:cs typeface="Yango Text" pitchFamily="34" charset="-120"/>
               </a:rPr>
-              <a:t>Monthly active AI users (10% of subscribers)</a:t>
+              <a:t>Monthly active AI users (% of subscribers)</a:t>
             </a:r>
             <a:endParaRPr lang="en-US" sz="1200" dirty="0"/>
           </a:p>
@@ -21833,7 +21833,7 @@
                 <a:ea typeface="Yango Text Bold" pitchFamily="34" charset="-122"/>
                 <a:cs typeface="Yango Text Bold" pitchFamily="34" charset="-120"/>
               </a:rPr>
-              <a:t>10M</a:t>
+              <a:t>xxM</a:t>
             </a:r>
             <a:endParaRPr lang="en-US" sz="1200" dirty="0"/>
           </a:p>
@@ -21931,7 +21931,7 @@
                 <a:ea typeface="Yango Text Bold" pitchFamily="34" charset="-122"/>
                 <a:cs typeface="Yango Text Bold" pitchFamily="34" charset="-120"/>
               </a:rPr>
-              <a:t>$0.80</a:t>
+              <a:t>$xx</a:t>
             </a:r>
             <a:endParaRPr lang="en-US" sz="1200" dirty="0"/>
           </a:p>
@@ -22029,7 +22029,7 @@
                 <a:ea typeface="Yango Text Bold" pitchFamily="34" charset="-122"/>
                 <a:cs typeface="Yango Text Bold" pitchFamily="34" charset="-120"/>
               </a:rPr>
-              <a:t>$8.0M</a:t>
+              <a:t>$xxM</a:t>
             </a:r>
             <a:endParaRPr lang="en-US" sz="1200" dirty="0"/>
           </a:p>
@@ -22088,7 +22088,7 @@
                 <a:ea typeface="Yango Text" pitchFamily="34" charset="-122"/>
                 <a:cs typeface="Yango Text" pitchFamily="34" charset="-120"/>
               </a:rPr>
-              <a:t>Platform take (25%)</a:t>
+              <a:t>Platform take (xx%)</a:t>
             </a:r>
             <a:endParaRPr lang="en-US" sz="1200" dirty="0"/>
           </a:p>
@@ -22127,7 +22127,7 @@
                 <a:ea typeface="Yango Text Bold" pitchFamily="34" charset="-122"/>
                 <a:cs typeface="Yango Text Bold" pitchFamily="34" charset="-120"/>
               </a:rPr>
-              <a:t>$2.0M / month</a:t>
+              <a:t>$xxM / month</a:t>
             </a:r>
             <a:endParaRPr lang="en-US" sz="1200" dirty="0"/>
           </a:p>
@@ -22225,7 +22225,7 @@
                 <a:ea typeface="Yango Text Bold" pitchFamily="34" charset="-122"/>
                 <a:cs typeface="Yango Text Bold" pitchFamily="34" charset="-120"/>
               </a:rPr>
-              <a:t>$1.2M / month</a:t>
+              <a:t>$xxM / month</a:t>
             </a:r>
             <a:endParaRPr lang="en-US" sz="1200" dirty="0"/>
           </a:p>
@@ -22323,7 +22323,7 @@
                 <a:ea typeface="Yango Headline Black" pitchFamily="34" charset="-122"/>
                 <a:cs typeface="Yango Headline Black" pitchFamily="34" charset="-120"/>
               </a:rPr>
-              <a:t>$3.2M</a:t>
+              <a:t>$xxM</a:t>
             </a:r>
             <a:endParaRPr lang="en-US" sz="2800" dirty="0"/>
           </a:p>

</xml_diff>